<commit_message>
Deploying to gh-pages from @ sean4andrew/safuncs@1122f4891df8998a18efeb8a03095c5b7f2ece7b 🚀
</commit_message>
<xml_diff>
--- a/reference/ONDA_XX-Hazard Curve.pptx
+++ b/reference/ONDA_XX-Hazard Curve.pptx
@@ -2250,9 +2250,9 @@
         <p:grpSpPr>
           <a:xfrm>
             <a:off x="914400" y="914400"/>
-            <a:ext cx="5486400" cy="3657600"/>
+            <a:ext cx="5303520" cy="4206240"/>
             <a:chOff x="914400" y="914400"/>
-            <a:chExt cx="5486400" cy="3657600"/>
+            <a:chExt cx="5303520" cy="4206240"/>
           </a:xfrm>
         </p:grpSpPr>
         <p:sp>
@@ -2264,7 +2264,7 @@
           <p:spPr>
             <a:xfrm>
               <a:off x="914400" y="914400"/>
-              <a:ext cx="5486400" cy="3657600"/>
+              <a:ext cx="5303520" cy="4206240"/>
             </a:xfrm>
             <a:prstGeom prst="rect">
               <a:avLst/>
@@ -2299,7 +2299,7 @@
           <p:spPr>
             <a:xfrm>
               <a:off x="914400" y="914400"/>
-              <a:ext cx="5486399" cy="3657600"/>
+              <a:ext cx="5303519" cy="4206240"/>
             </a:xfrm>
             <a:prstGeom prst="rect">
               <a:avLst/>
@@ -2333,8 +2333,8 @@
           </p:nvSpPr>
           <p:spPr>
             <a:xfrm>
-              <a:off x="1532259" y="983989"/>
-              <a:ext cx="4129871" cy="3185376"/>
+              <a:off x="1532030" y="983989"/>
+              <a:ext cx="3967704" cy="3733996"/>
             </a:xfrm>
             <a:prstGeom prst="rect">
               <a:avLst/>
@@ -2359,18 +2359,18 @@
           </p:nvSpPr>
           <p:spPr>
             <a:xfrm>
-              <a:off x="1532259" y="3909929"/>
-              <a:ext cx="4129871" cy="0"/>
+              <a:off x="1532030" y="4413866"/>
+              <a:ext cx="3967704" cy="0"/>
             </a:xfrm>
             <a:custGeom>
               <a:avLst/>
               <a:pathLst>
-                <a:path w="4129871" h="0">
+                <a:path w="3967704" h="0">
                   <a:moveTo>
                     <a:pt x="0" y="0"/>
                   </a:moveTo>
                   <a:lnTo>
-                    <a:pt x="4129871" y="0"/>
+                    <a:pt x="3967704" y="0"/>
                   </a:lnTo>
                 </a:path>
               </a:pathLst>
@@ -2399,18 +2399,18 @@
           </p:nvSpPr>
           <p:spPr>
             <a:xfrm>
-              <a:off x="1532259" y="3453515"/>
-              <a:ext cx="4129871" cy="0"/>
+              <a:off x="1532030" y="3878843"/>
+              <a:ext cx="3967704" cy="0"/>
             </a:xfrm>
             <a:custGeom>
               <a:avLst/>
               <a:pathLst>
-                <a:path w="4129871" h="0">
+                <a:path w="3967704" h="0">
                   <a:moveTo>
                     <a:pt x="0" y="0"/>
                   </a:moveTo>
                   <a:lnTo>
-                    <a:pt x="4129871" y="0"/>
+                    <a:pt x="3967704" y="0"/>
                   </a:lnTo>
                 </a:path>
               </a:pathLst>
@@ -2439,18 +2439,18 @@
           </p:nvSpPr>
           <p:spPr>
             <a:xfrm>
-              <a:off x="1532259" y="2997100"/>
-              <a:ext cx="4129871" cy="0"/>
+              <a:off x="1532030" y="3343820"/>
+              <a:ext cx="3967704" cy="0"/>
             </a:xfrm>
             <a:custGeom>
               <a:avLst/>
               <a:pathLst>
-                <a:path w="4129871" h="0">
+                <a:path w="3967704" h="0">
                   <a:moveTo>
                     <a:pt x="0" y="0"/>
                   </a:moveTo>
                   <a:lnTo>
-                    <a:pt x="4129871" y="0"/>
+                    <a:pt x="3967704" y="0"/>
                   </a:lnTo>
                 </a:path>
               </a:pathLst>
@@ -2479,18 +2479,18 @@
           </p:nvSpPr>
           <p:spPr>
             <a:xfrm>
-              <a:off x="1532259" y="2540686"/>
-              <a:ext cx="4129871" cy="0"/>
+              <a:off x="1532030" y="2808798"/>
+              <a:ext cx="3967704" cy="0"/>
             </a:xfrm>
             <a:custGeom>
               <a:avLst/>
               <a:pathLst>
-                <a:path w="4129871" h="0">
+                <a:path w="3967704" h="0">
                   <a:moveTo>
                     <a:pt x="0" y="0"/>
                   </a:moveTo>
                   <a:lnTo>
-                    <a:pt x="4129871" y="0"/>
+                    <a:pt x="3967704" y="0"/>
                   </a:lnTo>
                 </a:path>
               </a:pathLst>
@@ -2519,18 +2519,18 @@
           </p:nvSpPr>
           <p:spPr>
             <a:xfrm>
-              <a:off x="1532259" y="2084272"/>
-              <a:ext cx="4129871" cy="0"/>
+              <a:off x="1532030" y="2273775"/>
+              <a:ext cx="3967704" cy="0"/>
             </a:xfrm>
             <a:custGeom>
               <a:avLst/>
               <a:pathLst>
-                <a:path w="4129871" h="0">
+                <a:path w="3967704" h="0">
                   <a:moveTo>
                     <a:pt x="0" y="0"/>
                   </a:moveTo>
                   <a:lnTo>
-                    <a:pt x="4129871" y="0"/>
+                    <a:pt x="3967704" y="0"/>
                   </a:lnTo>
                 </a:path>
               </a:pathLst>
@@ -2559,18 +2559,18 @@
           </p:nvSpPr>
           <p:spPr>
             <a:xfrm>
-              <a:off x="1532259" y="1627858"/>
-              <a:ext cx="4129871" cy="0"/>
+              <a:off x="1532030" y="1738752"/>
+              <a:ext cx="3967704" cy="0"/>
             </a:xfrm>
             <a:custGeom>
               <a:avLst/>
               <a:pathLst>
-                <a:path w="4129871" h="0">
+                <a:path w="3967704" h="0">
                   <a:moveTo>
                     <a:pt x="0" y="0"/>
                   </a:moveTo>
                   <a:lnTo>
-                    <a:pt x="4129871" y="0"/>
+                    <a:pt x="3967704" y="0"/>
                   </a:lnTo>
                 </a:path>
               </a:pathLst>
@@ -2599,18 +2599,18 @@
           </p:nvSpPr>
           <p:spPr>
             <a:xfrm>
-              <a:off x="1532259" y="1171444"/>
-              <a:ext cx="4129871" cy="0"/>
+              <a:off x="1532030" y="1203730"/>
+              <a:ext cx="3967704" cy="0"/>
             </a:xfrm>
             <a:custGeom>
               <a:avLst/>
               <a:pathLst>
-                <a:path w="4129871" h="0">
+                <a:path w="3967704" h="0">
                   <a:moveTo>
                     <a:pt x="0" y="0"/>
                   </a:moveTo>
                   <a:lnTo>
-                    <a:pt x="4129871" y="0"/>
+                    <a:pt x="3967704" y="0"/>
                   </a:lnTo>
                 </a:path>
               </a:pathLst>
@@ -2639,15 +2639,15 @@
           </p:nvSpPr>
           <p:spPr>
             <a:xfrm>
-              <a:off x="1757525" y="983989"/>
-              <a:ext cx="0" cy="3185376"/>
+              <a:off x="1748450" y="983989"/>
+              <a:ext cx="0" cy="3733996"/>
             </a:xfrm>
             <a:custGeom>
               <a:avLst/>
               <a:pathLst>
-                <a:path w="0" h="3185376">
+                <a:path w="0" h="3733996">
                   <a:moveTo>
-                    <a:pt x="0" y="3185376"/>
+                    <a:pt x="0" y="3733996"/>
                   </a:moveTo>
                   <a:lnTo>
                     <a:pt x="0" y="0"/>
@@ -2679,15 +2679,15 @@
           </p:nvSpPr>
           <p:spPr>
             <a:xfrm>
-              <a:off x="2208057" y="983989"/>
-              <a:ext cx="0" cy="3185376"/>
+              <a:off x="2181290" y="983989"/>
+              <a:ext cx="0" cy="3733996"/>
             </a:xfrm>
             <a:custGeom>
               <a:avLst/>
               <a:pathLst>
-                <a:path w="0" h="3185376">
+                <a:path w="0" h="3733996">
                   <a:moveTo>
-                    <a:pt x="0" y="3185376"/>
+                    <a:pt x="0" y="3733996"/>
                   </a:moveTo>
                   <a:lnTo>
                     <a:pt x="0" y="0"/>
@@ -2719,15 +2719,15 @@
           </p:nvSpPr>
           <p:spPr>
             <a:xfrm>
-              <a:off x="2658588" y="983989"/>
-              <a:ext cx="0" cy="3185376"/>
+              <a:off x="2614131" y="983989"/>
+              <a:ext cx="0" cy="3733996"/>
             </a:xfrm>
             <a:custGeom>
               <a:avLst/>
               <a:pathLst>
-                <a:path w="0" h="3185376">
+                <a:path w="0" h="3733996">
                   <a:moveTo>
-                    <a:pt x="0" y="3185376"/>
+                    <a:pt x="0" y="3733996"/>
                   </a:moveTo>
                   <a:lnTo>
                     <a:pt x="0" y="0"/>
@@ -2759,15 +2759,15 @@
           </p:nvSpPr>
           <p:spPr>
             <a:xfrm>
-              <a:off x="3109119" y="983989"/>
-              <a:ext cx="0" cy="3185376"/>
+              <a:off x="3046971" y="983989"/>
+              <a:ext cx="0" cy="3733996"/>
             </a:xfrm>
             <a:custGeom>
               <a:avLst/>
               <a:pathLst>
-                <a:path w="0" h="3185376">
+                <a:path w="0" h="3733996">
                   <a:moveTo>
-                    <a:pt x="0" y="3185376"/>
+                    <a:pt x="0" y="3733996"/>
                   </a:moveTo>
                   <a:lnTo>
                     <a:pt x="0" y="0"/>
@@ -2799,15 +2799,15 @@
           </p:nvSpPr>
           <p:spPr>
             <a:xfrm>
-              <a:off x="3559651" y="983989"/>
-              <a:ext cx="0" cy="3185376"/>
+              <a:off x="3479812" y="983989"/>
+              <a:ext cx="0" cy="3733996"/>
             </a:xfrm>
             <a:custGeom>
               <a:avLst/>
               <a:pathLst>
-                <a:path w="0" h="3185376">
+                <a:path w="0" h="3733996">
                   <a:moveTo>
-                    <a:pt x="0" y="3185376"/>
+                    <a:pt x="0" y="3733996"/>
                   </a:moveTo>
                   <a:lnTo>
                     <a:pt x="0" y="0"/>
@@ -2839,15 +2839,15 @@
           </p:nvSpPr>
           <p:spPr>
             <a:xfrm>
-              <a:off x="4010182" y="983989"/>
-              <a:ext cx="0" cy="3185376"/>
+              <a:off x="3912652" y="983989"/>
+              <a:ext cx="0" cy="3733996"/>
             </a:xfrm>
             <a:custGeom>
               <a:avLst/>
               <a:pathLst>
-                <a:path w="0" h="3185376">
+                <a:path w="0" h="3733996">
                   <a:moveTo>
-                    <a:pt x="0" y="3185376"/>
+                    <a:pt x="0" y="3733996"/>
                   </a:moveTo>
                   <a:lnTo>
                     <a:pt x="0" y="0"/>
@@ -2879,15 +2879,15 @@
           </p:nvSpPr>
           <p:spPr>
             <a:xfrm>
-              <a:off x="4460714" y="983989"/>
-              <a:ext cx="0" cy="3185376"/>
+              <a:off x="4345493" y="983989"/>
+              <a:ext cx="0" cy="3733996"/>
             </a:xfrm>
             <a:custGeom>
               <a:avLst/>
               <a:pathLst>
-                <a:path w="0" h="3185376">
+                <a:path w="0" h="3733996">
                   <a:moveTo>
-                    <a:pt x="0" y="3185376"/>
+                    <a:pt x="0" y="3733996"/>
                   </a:moveTo>
                   <a:lnTo>
                     <a:pt x="0" y="0"/>
@@ -2919,15 +2919,15 @@
           </p:nvSpPr>
           <p:spPr>
             <a:xfrm>
-              <a:off x="4911245" y="983989"/>
-              <a:ext cx="0" cy="3185376"/>
+              <a:off x="4778333" y="983989"/>
+              <a:ext cx="0" cy="3733996"/>
             </a:xfrm>
             <a:custGeom>
               <a:avLst/>
               <a:pathLst>
-                <a:path w="0" h="3185376">
+                <a:path w="0" h="3733996">
                   <a:moveTo>
-                    <a:pt x="0" y="3185376"/>
+                    <a:pt x="0" y="3733996"/>
                   </a:moveTo>
                   <a:lnTo>
                     <a:pt x="0" y="0"/>
@@ -2959,15 +2959,15 @@
           </p:nvSpPr>
           <p:spPr>
             <a:xfrm>
-              <a:off x="5361777" y="983989"/>
-              <a:ext cx="0" cy="3185376"/>
+              <a:off x="5211173" y="983989"/>
+              <a:ext cx="0" cy="3733996"/>
             </a:xfrm>
             <a:custGeom>
               <a:avLst/>
               <a:pathLst>
-                <a:path w="0" h="3185376">
+                <a:path w="0" h="3733996">
                   <a:moveTo>
-                    <a:pt x="0" y="3185376"/>
+                    <a:pt x="0" y="3733996"/>
                   </a:moveTo>
                   <a:lnTo>
                     <a:pt x="0" y="0"/>
@@ -2999,18 +2999,18 @@
           </p:nvSpPr>
           <p:spPr>
             <a:xfrm>
-              <a:off x="1532259" y="4138136"/>
-              <a:ext cx="4129871" cy="0"/>
+              <a:off x="1532030" y="4681377"/>
+              <a:ext cx="3967704" cy="0"/>
             </a:xfrm>
             <a:custGeom>
               <a:avLst/>
               <a:pathLst>
-                <a:path w="4129871" h="0">
+                <a:path w="3967704" h="0">
                   <a:moveTo>
                     <a:pt x="0" y="0"/>
                   </a:moveTo>
                   <a:lnTo>
-                    <a:pt x="4129871" y="0"/>
+                    <a:pt x="3967704" y="0"/>
                   </a:lnTo>
                 </a:path>
               </a:pathLst>
@@ -3039,18 +3039,18 @@
           </p:nvSpPr>
           <p:spPr>
             <a:xfrm>
-              <a:off x="1532259" y="3681722"/>
-              <a:ext cx="4129871" cy="0"/>
+              <a:off x="1532030" y="4146354"/>
+              <a:ext cx="3967704" cy="0"/>
             </a:xfrm>
             <a:custGeom>
               <a:avLst/>
               <a:pathLst>
-                <a:path w="4129871" h="0">
+                <a:path w="3967704" h="0">
                   <a:moveTo>
                     <a:pt x="0" y="0"/>
                   </a:moveTo>
                   <a:lnTo>
-                    <a:pt x="4129871" y="0"/>
+                    <a:pt x="3967704" y="0"/>
                   </a:lnTo>
                 </a:path>
               </a:pathLst>
@@ -3079,18 +3079,18 @@
           </p:nvSpPr>
           <p:spPr>
             <a:xfrm>
-              <a:off x="1532259" y="3225307"/>
-              <a:ext cx="4129871" cy="0"/>
+              <a:off x="1532030" y="3611332"/>
+              <a:ext cx="3967704" cy="0"/>
             </a:xfrm>
             <a:custGeom>
               <a:avLst/>
               <a:pathLst>
-                <a:path w="4129871" h="0">
+                <a:path w="3967704" h="0">
                   <a:moveTo>
                     <a:pt x="0" y="0"/>
                   </a:moveTo>
                   <a:lnTo>
-                    <a:pt x="4129871" y="0"/>
+                    <a:pt x="3967704" y="0"/>
                   </a:lnTo>
                 </a:path>
               </a:pathLst>
@@ -3119,18 +3119,18 @@
           </p:nvSpPr>
           <p:spPr>
             <a:xfrm>
-              <a:off x="1532259" y="2768893"/>
-              <a:ext cx="4129871" cy="0"/>
+              <a:off x="1532030" y="3076309"/>
+              <a:ext cx="3967704" cy="0"/>
             </a:xfrm>
             <a:custGeom>
               <a:avLst/>
               <a:pathLst>
-                <a:path w="4129871" h="0">
+                <a:path w="3967704" h="0">
                   <a:moveTo>
                     <a:pt x="0" y="0"/>
                   </a:moveTo>
                   <a:lnTo>
-                    <a:pt x="4129871" y="0"/>
+                    <a:pt x="3967704" y="0"/>
                   </a:lnTo>
                 </a:path>
               </a:pathLst>
@@ -3159,18 +3159,18 @@
           </p:nvSpPr>
           <p:spPr>
             <a:xfrm>
-              <a:off x="1532259" y="2312479"/>
-              <a:ext cx="4129871" cy="0"/>
+              <a:off x="1532030" y="2541286"/>
+              <a:ext cx="3967704" cy="0"/>
             </a:xfrm>
             <a:custGeom>
               <a:avLst/>
               <a:pathLst>
-                <a:path w="4129871" h="0">
+                <a:path w="3967704" h="0">
                   <a:moveTo>
                     <a:pt x="0" y="0"/>
                   </a:moveTo>
                   <a:lnTo>
-                    <a:pt x="4129871" y="0"/>
+                    <a:pt x="3967704" y="0"/>
                   </a:lnTo>
                 </a:path>
               </a:pathLst>
@@ -3199,18 +3199,18 @@
           </p:nvSpPr>
           <p:spPr>
             <a:xfrm>
-              <a:off x="1532259" y="1856065"/>
-              <a:ext cx="4129871" cy="0"/>
+              <a:off x="1532030" y="2006264"/>
+              <a:ext cx="3967704" cy="0"/>
             </a:xfrm>
             <a:custGeom>
               <a:avLst/>
               <a:pathLst>
-                <a:path w="4129871" h="0">
+                <a:path w="3967704" h="0">
                   <a:moveTo>
                     <a:pt x="0" y="0"/>
                   </a:moveTo>
                   <a:lnTo>
-                    <a:pt x="4129871" y="0"/>
+                    <a:pt x="3967704" y="0"/>
                   </a:lnTo>
                 </a:path>
               </a:pathLst>
@@ -3239,18 +3239,18 @@
           </p:nvSpPr>
           <p:spPr>
             <a:xfrm>
-              <a:off x="1532259" y="1399651"/>
-              <a:ext cx="4129871" cy="0"/>
+              <a:off x="1532030" y="1471241"/>
+              <a:ext cx="3967704" cy="0"/>
             </a:xfrm>
             <a:custGeom>
               <a:avLst/>
               <a:pathLst>
-                <a:path w="4129871" h="0">
+                <a:path w="3967704" h="0">
                   <a:moveTo>
                     <a:pt x="0" y="0"/>
                   </a:moveTo>
                   <a:lnTo>
-                    <a:pt x="4129871" y="0"/>
+                    <a:pt x="3967704" y="0"/>
                   </a:lnTo>
                 </a:path>
               </a:pathLst>
@@ -3279,15 +3279,15 @@
           </p:nvSpPr>
           <p:spPr>
             <a:xfrm>
-              <a:off x="1532259" y="983989"/>
-              <a:ext cx="0" cy="3185376"/>
+              <a:off x="1532030" y="983989"/>
+              <a:ext cx="0" cy="3733996"/>
             </a:xfrm>
             <a:custGeom>
               <a:avLst/>
               <a:pathLst>
-                <a:path w="0" h="3185376">
+                <a:path w="0" h="3733996">
                   <a:moveTo>
-                    <a:pt x="0" y="3185376"/>
+                    <a:pt x="0" y="3733996"/>
                   </a:moveTo>
                   <a:lnTo>
                     <a:pt x="0" y="0"/>
@@ -3319,15 +3319,15 @@
           </p:nvSpPr>
           <p:spPr>
             <a:xfrm>
-              <a:off x="1982791" y="983989"/>
-              <a:ext cx="0" cy="3185376"/>
+              <a:off x="1964870" y="983989"/>
+              <a:ext cx="0" cy="3733996"/>
             </a:xfrm>
             <a:custGeom>
               <a:avLst/>
               <a:pathLst>
-                <a:path w="0" h="3185376">
+                <a:path w="0" h="3733996">
                   <a:moveTo>
-                    <a:pt x="0" y="3185376"/>
+                    <a:pt x="0" y="3733996"/>
                   </a:moveTo>
                   <a:lnTo>
                     <a:pt x="0" y="0"/>
@@ -3359,15 +3359,15 @@
           </p:nvSpPr>
           <p:spPr>
             <a:xfrm>
-              <a:off x="2433322" y="983989"/>
-              <a:ext cx="0" cy="3185376"/>
+              <a:off x="2397710" y="983989"/>
+              <a:ext cx="0" cy="3733996"/>
             </a:xfrm>
             <a:custGeom>
               <a:avLst/>
               <a:pathLst>
-                <a:path w="0" h="3185376">
+                <a:path w="0" h="3733996">
                   <a:moveTo>
-                    <a:pt x="0" y="3185376"/>
+                    <a:pt x="0" y="3733996"/>
                   </a:moveTo>
                   <a:lnTo>
                     <a:pt x="0" y="0"/>
@@ -3399,15 +3399,15 @@
           </p:nvSpPr>
           <p:spPr>
             <a:xfrm>
-              <a:off x="2883854" y="983989"/>
-              <a:ext cx="0" cy="3185376"/>
+              <a:off x="2830551" y="983989"/>
+              <a:ext cx="0" cy="3733996"/>
             </a:xfrm>
             <a:custGeom>
               <a:avLst/>
               <a:pathLst>
-                <a:path w="0" h="3185376">
+                <a:path w="0" h="3733996">
                   <a:moveTo>
-                    <a:pt x="0" y="3185376"/>
+                    <a:pt x="0" y="3733996"/>
                   </a:moveTo>
                   <a:lnTo>
                     <a:pt x="0" y="0"/>
@@ -3439,15 +3439,15 @@
           </p:nvSpPr>
           <p:spPr>
             <a:xfrm>
-              <a:off x="3334385" y="983989"/>
-              <a:ext cx="0" cy="3185376"/>
+              <a:off x="3263391" y="983989"/>
+              <a:ext cx="0" cy="3733996"/>
             </a:xfrm>
             <a:custGeom>
               <a:avLst/>
               <a:pathLst>
-                <a:path w="0" h="3185376">
+                <a:path w="0" h="3733996">
                   <a:moveTo>
-                    <a:pt x="0" y="3185376"/>
+                    <a:pt x="0" y="3733996"/>
                   </a:moveTo>
                   <a:lnTo>
                     <a:pt x="0" y="0"/>
@@ -3479,15 +3479,15 @@
           </p:nvSpPr>
           <p:spPr>
             <a:xfrm>
-              <a:off x="3784917" y="983989"/>
-              <a:ext cx="0" cy="3185376"/>
+              <a:off x="3696232" y="983989"/>
+              <a:ext cx="0" cy="3733996"/>
             </a:xfrm>
             <a:custGeom>
               <a:avLst/>
               <a:pathLst>
-                <a:path w="0" h="3185376">
+                <a:path w="0" h="3733996">
                   <a:moveTo>
-                    <a:pt x="0" y="3185376"/>
+                    <a:pt x="0" y="3733996"/>
                   </a:moveTo>
                   <a:lnTo>
                     <a:pt x="0" y="0"/>
@@ -3519,15 +3519,15 @@
           </p:nvSpPr>
           <p:spPr>
             <a:xfrm>
-              <a:off x="4235448" y="983989"/>
-              <a:ext cx="0" cy="3185376"/>
+              <a:off x="4129072" y="983989"/>
+              <a:ext cx="0" cy="3733996"/>
             </a:xfrm>
             <a:custGeom>
               <a:avLst/>
               <a:pathLst>
-                <a:path w="0" h="3185376">
+                <a:path w="0" h="3733996">
                   <a:moveTo>
-                    <a:pt x="0" y="3185376"/>
+                    <a:pt x="0" y="3733996"/>
                   </a:moveTo>
                   <a:lnTo>
                     <a:pt x="0" y="0"/>
@@ -3559,15 +3559,15 @@
           </p:nvSpPr>
           <p:spPr>
             <a:xfrm>
-              <a:off x="4685979" y="983989"/>
-              <a:ext cx="0" cy="3185376"/>
+              <a:off x="4561913" y="983989"/>
+              <a:ext cx="0" cy="3733996"/>
             </a:xfrm>
             <a:custGeom>
               <a:avLst/>
               <a:pathLst>
-                <a:path w="0" h="3185376">
+                <a:path w="0" h="3733996">
                   <a:moveTo>
-                    <a:pt x="0" y="3185376"/>
+                    <a:pt x="0" y="3733996"/>
                   </a:moveTo>
                   <a:lnTo>
                     <a:pt x="0" y="0"/>
@@ -3599,15 +3599,15 @@
           </p:nvSpPr>
           <p:spPr>
             <a:xfrm>
-              <a:off x="5136511" y="983989"/>
-              <a:ext cx="0" cy="3185376"/>
+              <a:off x="4994753" y="983989"/>
+              <a:ext cx="0" cy="3733996"/>
             </a:xfrm>
             <a:custGeom>
               <a:avLst/>
               <a:pathLst>
-                <a:path w="0" h="3185376">
+                <a:path w="0" h="3733996">
                   <a:moveTo>
-                    <a:pt x="0" y="3185376"/>
+                    <a:pt x="0" y="3733996"/>
                   </a:moveTo>
                   <a:lnTo>
                     <a:pt x="0" y="0"/>
@@ -3639,15 +3639,15 @@
           </p:nvSpPr>
           <p:spPr>
             <a:xfrm>
-              <a:off x="5587042" y="983989"/>
-              <a:ext cx="0" cy="3185376"/>
+              <a:off x="5427594" y="983989"/>
+              <a:ext cx="0" cy="3733996"/>
             </a:xfrm>
             <a:custGeom>
               <a:avLst/>
               <a:pathLst>
-                <a:path w="0" h="3185376">
+                <a:path w="0" h="3733996">
                   <a:moveTo>
-                    <a:pt x="0" y="3185376"/>
+                    <a:pt x="0" y="3733996"/>
                   </a:moveTo>
                   <a:lnTo>
                     <a:pt x="0" y="0"/>
@@ -3679,174 +3679,174 @@
           </p:nvSpPr>
           <p:spPr>
             <a:xfrm>
-              <a:off x="1569804" y="1015218"/>
-              <a:ext cx="3979694" cy="3122917"/>
+              <a:off x="1568100" y="1020596"/>
+              <a:ext cx="3823424" cy="3660780"/>
             </a:xfrm>
             <a:custGeom>
               <a:avLst/>
               <a:pathLst>
-                <a:path w="3979694" h="3122917">
+                <a:path w="3823424" h="3660780">
                   <a:moveTo>
-                    <a:pt x="0" y="3122917"/>
+                    <a:pt x="0" y="3660780"/>
                   </a:moveTo>
                   <a:lnTo>
-                    <a:pt x="75088" y="3122917"/>
-                  </a:lnTo>
-                  <a:lnTo>
-                    <a:pt x="150177" y="3122917"/>
-                  </a:lnTo>
-                  <a:lnTo>
-                    <a:pt x="225265" y="3122917"/>
-                  </a:lnTo>
-                  <a:lnTo>
-                    <a:pt x="300354" y="3122917"/>
-                  </a:lnTo>
-                  <a:lnTo>
-                    <a:pt x="375442" y="3122917"/>
-                  </a:lnTo>
-                  <a:lnTo>
-                    <a:pt x="450531" y="3122917"/>
-                  </a:lnTo>
-                  <a:lnTo>
-                    <a:pt x="525619" y="3122916"/>
-                  </a:lnTo>
-                  <a:lnTo>
-                    <a:pt x="600708" y="3122913"/>
-                  </a:lnTo>
-                  <a:lnTo>
-                    <a:pt x="675797" y="3122909"/>
-                  </a:lnTo>
-                  <a:lnTo>
-                    <a:pt x="750885" y="3122900"/>
-                  </a:lnTo>
-                  <a:lnTo>
-                    <a:pt x="825974" y="3122880"/>
-                  </a:lnTo>
-                  <a:lnTo>
-                    <a:pt x="901062" y="3122838"/>
-                  </a:lnTo>
-                  <a:lnTo>
-                    <a:pt x="976151" y="3122750"/>
-                  </a:lnTo>
-                  <a:lnTo>
-                    <a:pt x="1051239" y="3122563"/>
-                  </a:lnTo>
-                  <a:lnTo>
-                    <a:pt x="1126328" y="3122169"/>
-                  </a:lnTo>
-                  <a:lnTo>
-                    <a:pt x="1201417" y="3121336"/>
-                  </a:lnTo>
-                  <a:lnTo>
-                    <a:pt x="1276505" y="3119583"/>
-                  </a:lnTo>
-                  <a:lnTo>
-                    <a:pt x="1351594" y="3115899"/>
-                  </a:lnTo>
-                  <a:lnTo>
-                    <a:pt x="1426682" y="3108201"/>
-                  </a:lnTo>
-                  <a:lnTo>
-                    <a:pt x="1501771" y="3092430"/>
-                  </a:lnTo>
-                  <a:lnTo>
-                    <a:pt x="1576859" y="3060338"/>
-                  </a:lnTo>
-                  <a:lnTo>
-                    <a:pt x="1651948" y="3002179"/>
-                  </a:lnTo>
-                  <a:lnTo>
-                    <a:pt x="1727037" y="2894308"/>
-                  </a:lnTo>
-                  <a:lnTo>
-                    <a:pt x="1802125" y="2729738"/>
-                  </a:lnTo>
-                  <a:lnTo>
-                    <a:pt x="1877214" y="2519460"/>
-                  </a:lnTo>
-                  <a:lnTo>
-                    <a:pt x="1952302" y="2445681"/>
-                  </a:lnTo>
-                  <a:lnTo>
-                    <a:pt x="2027391" y="2385366"/>
-                  </a:lnTo>
-                  <a:lnTo>
-                    <a:pt x="2102479" y="2343442"/>
-                  </a:lnTo>
-                  <a:lnTo>
-                    <a:pt x="2177568" y="2130614"/>
-                  </a:lnTo>
-                  <a:lnTo>
-                    <a:pt x="2252657" y="1771219"/>
-                  </a:lnTo>
-                  <a:lnTo>
-                    <a:pt x="2327745" y="1371083"/>
-                  </a:lnTo>
-                  <a:lnTo>
-                    <a:pt x="2402834" y="904348"/>
-                  </a:lnTo>
-                  <a:lnTo>
-                    <a:pt x="2477922" y="543623"/>
-                  </a:lnTo>
-                  <a:lnTo>
-                    <a:pt x="2553011" y="222377"/>
-                  </a:lnTo>
-                  <a:lnTo>
-                    <a:pt x="2628099" y="0"/>
-                  </a:lnTo>
-                  <a:lnTo>
-                    <a:pt x="2703188" y="439234"/>
-                  </a:lnTo>
-                  <a:lnTo>
-                    <a:pt x="2778277" y="1062545"/>
-                  </a:lnTo>
-                  <a:lnTo>
-                    <a:pt x="2853365" y="1427455"/>
-                  </a:lnTo>
-                  <a:lnTo>
-                    <a:pt x="2928454" y="1736034"/>
-                  </a:lnTo>
-                  <a:lnTo>
-                    <a:pt x="3003542" y="2084929"/>
-                  </a:lnTo>
-                  <a:lnTo>
-                    <a:pt x="3078631" y="2245408"/>
-                  </a:lnTo>
-                  <a:lnTo>
-                    <a:pt x="3153719" y="2207333"/>
-                  </a:lnTo>
-                  <a:lnTo>
-                    <a:pt x="3228808" y="2041881"/>
-                  </a:lnTo>
-                  <a:lnTo>
-                    <a:pt x="3303897" y="1736861"/>
-                  </a:lnTo>
-                  <a:lnTo>
-                    <a:pt x="3378985" y="1535770"/>
-                  </a:lnTo>
-                  <a:lnTo>
-                    <a:pt x="3454074" y="1371044"/>
-                  </a:lnTo>
-                  <a:lnTo>
-                    <a:pt x="3529162" y="1535974"/>
-                  </a:lnTo>
-                  <a:lnTo>
-                    <a:pt x="3604251" y="1839376"/>
-                  </a:lnTo>
-                  <a:lnTo>
-                    <a:pt x="3679339" y="2325970"/>
-                  </a:lnTo>
-                  <a:lnTo>
-                    <a:pt x="3754428" y="2634774"/>
-                  </a:lnTo>
-                  <a:lnTo>
-                    <a:pt x="3829517" y="2827456"/>
-                  </a:lnTo>
-                  <a:lnTo>
-                    <a:pt x="3904605" y="2921566"/>
-                  </a:lnTo>
-                  <a:lnTo>
-                    <a:pt x="3979694" y="2980656"/>
+                    <a:pt x="72140" y="3660780"/>
+                  </a:lnTo>
+                  <a:lnTo>
+                    <a:pt x="144280" y="3660780"/>
+                  </a:lnTo>
+                  <a:lnTo>
+                    <a:pt x="216420" y="3660780"/>
+                  </a:lnTo>
+                  <a:lnTo>
+                    <a:pt x="288560" y="3660780"/>
+                  </a:lnTo>
+                  <a:lnTo>
+                    <a:pt x="360700" y="3660780"/>
+                  </a:lnTo>
+                  <a:lnTo>
+                    <a:pt x="432840" y="3660779"/>
+                  </a:lnTo>
+                  <a:lnTo>
+                    <a:pt x="504980" y="3660778"/>
+                  </a:lnTo>
+                  <a:lnTo>
+                    <a:pt x="577120" y="3660776"/>
+                  </a:lnTo>
+                  <a:lnTo>
+                    <a:pt x="649260" y="3660770"/>
+                  </a:lnTo>
+                  <a:lnTo>
+                    <a:pt x="721400" y="3660759"/>
+                  </a:lnTo>
+                  <a:lnTo>
+                    <a:pt x="793540" y="3660736"/>
+                  </a:lnTo>
+                  <a:lnTo>
+                    <a:pt x="865680" y="3660687"/>
+                  </a:lnTo>
+                  <a:lnTo>
+                    <a:pt x="937820" y="3660584"/>
+                  </a:lnTo>
+                  <a:lnTo>
+                    <a:pt x="1009961" y="3660365"/>
+                  </a:lnTo>
+                  <a:lnTo>
+                    <a:pt x="1082101" y="3659903"/>
+                  </a:lnTo>
+                  <a:lnTo>
+                    <a:pt x="1154241" y="3658927"/>
+                  </a:lnTo>
+                  <a:lnTo>
+                    <a:pt x="1226381" y="3656872"/>
+                  </a:lnTo>
+                  <a:lnTo>
+                    <a:pt x="1298521" y="3652554"/>
+                  </a:lnTo>
+                  <a:lnTo>
+                    <a:pt x="1370661" y="3643530"/>
+                  </a:lnTo>
+                  <a:lnTo>
+                    <a:pt x="1442801" y="3625042"/>
+                  </a:lnTo>
+                  <a:lnTo>
+                    <a:pt x="1514941" y="3587423"/>
+                  </a:lnTo>
+                  <a:lnTo>
+                    <a:pt x="1587081" y="3519247"/>
+                  </a:lnTo>
+                  <a:lnTo>
+                    <a:pt x="1659221" y="3392798"/>
+                  </a:lnTo>
+                  <a:lnTo>
+                    <a:pt x="1731361" y="3199883"/>
+                  </a:lnTo>
+                  <a:lnTo>
+                    <a:pt x="1803501" y="2953389"/>
+                  </a:lnTo>
+                  <a:lnTo>
+                    <a:pt x="1875641" y="2866903"/>
+                  </a:lnTo>
+                  <a:lnTo>
+                    <a:pt x="1947782" y="2796200"/>
+                  </a:lnTo>
+                  <a:lnTo>
+                    <a:pt x="2019922" y="2747055"/>
+                  </a:lnTo>
+                  <a:lnTo>
+                    <a:pt x="2092062" y="2497572"/>
+                  </a:lnTo>
+                  <a:lnTo>
+                    <a:pt x="2164202" y="2076277"/>
+                  </a:lnTo>
+                  <a:lnTo>
+                    <a:pt x="2236342" y="1607225"/>
+                  </a:lnTo>
+                  <a:lnTo>
+                    <a:pt x="2308482" y="1060105"/>
+                  </a:lnTo>
+                  <a:lnTo>
+                    <a:pt x="2380622" y="637251"/>
+                  </a:lnTo>
+                  <a:lnTo>
+                    <a:pt x="2452762" y="260677"/>
+                  </a:lnTo>
+                  <a:lnTo>
+                    <a:pt x="2524902" y="0"/>
+                  </a:lnTo>
+                  <a:lnTo>
+                    <a:pt x="2597042" y="514884"/>
+                  </a:lnTo>
+                  <a:lnTo>
+                    <a:pt x="2669182" y="1245548"/>
+                  </a:lnTo>
+                  <a:lnTo>
+                    <a:pt x="2741322" y="1673307"/>
+                  </a:lnTo>
+                  <a:lnTo>
+                    <a:pt x="2813462" y="2035032"/>
+                  </a:lnTo>
+                  <a:lnTo>
+                    <a:pt x="2885603" y="2444018"/>
+                  </a:lnTo>
+                  <a:lnTo>
+                    <a:pt x="2957743" y="2632136"/>
+                  </a:lnTo>
+                  <a:lnTo>
+                    <a:pt x="3029883" y="2587504"/>
+                  </a:lnTo>
+                  <a:lnTo>
+                    <a:pt x="3102023" y="2393556"/>
+                  </a:lnTo>
+                  <a:lnTo>
+                    <a:pt x="3174163" y="2036003"/>
+                  </a:lnTo>
+                  <a:lnTo>
+                    <a:pt x="3246303" y="1800277"/>
+                  </a:lnTo>
+                  <a:lnTo>
+                    <a:pt x="3318443" y="1607180"/>
+                  </a:lnTo>
+                  <a:lnTo>
+                    <a:pt x="3390583" y="1800516"/>
+                  </a:lnTo>
+                  <a:lnTo>
+                    <a:pt x="3462723" y="2156173"/>
+                  </a:lnTo>
+                  <a:lnTo>
+                    <a:pt x="3534863" y="2726574"/>
+                  </a:lnTo>
+                  <a:lnTo>
+                    <a:pt x="3607003" y="3088564"/>
+                  </a:lnTo>
+                  <a:lnTo>
+                    <a:pt x="3679143" y="3314432"/>
+                  </a:lnTo>
+                  <a:lnTo>
+                    <a:pt x="3751283" y="3424749"/>
+                  </a:lnTo>
+                  <a:lnTo>
+                    <a:pt x="3823424" y="3494017"/>
                   </a:lnTo>
                 </a:path>
               </a:pathLst>
@@ -3875,7 +3875,7 @@
           </p:nvSpPr>
           <p:spPr>
             <a:xfrm>
-              <a:off x="1544978" y="4113310"/>
+              <a:off x="1543274" y="4656551"/>
               <a:ext cx="49651" cy="49651"/>
             </a:xfrm>
             <a:prstGeom prst="ellipse">
@@ -3910,7 +3910,7 @@
           </p:nvSpPr>
           <p:spPr>
             <a:xfrm>
-              <a:off x="1620066" y="4113310"/>
+              <a:off x="1615414" y="4656551"/>
               <a:ext cx="49651" cy="49651"/>
             </a:xfrm>
             <a:prstGeom prst="ellipse">
@@ -3945,7 +3945,7 @@
           </p:nvSpPr>
           <p:spPr>
             <a:xfrm>
-              <a:off x="1695155" y="4113310"/>
+              <a:off x="1687554" y="4656551"/>
               <a:ext cx="49651" cy="49651"/>
             </a:xfrm>
             <a:prstGeom prst="ellipse">
@@ -3980,7 +3980,7 @@
           </p:nvSpPr>
           <p:spPr>
             <a:xfrm>
-              <a:off x="1770244" y="4113310"/>
+              <a:off x="1759694" y="4656551"/>
               <a:ext cx="49651" cy="49651"/>
             </a:xfrm>
             <a:prstGeom prst="ellipse">
@@ -4015,7 +4015,7 @@
           </p:nvSpPr>
           <p:spPr>
             <a:xfrm>
-              <a:off x="1845332" y="4113310"/>
+              <a:off x="1831834" y="4656551"/>
               <a:ext cx="49651" cy="49651"/>
             </a:xfrm>
             <a:prstGeom prst="ellipse">
@@ -4050,7 +4050,7 @@
           </p:nvSpPr>
           <p:spPr>
             <a:xfrm>
-              <a:off x="1920421" y="4113309"/>
+              <a:off x="1903974" y="4656551"/>
               <a:ext cx="49651" cy="49651"/>
             </a:xfrm>
             <a:prstGeom prst="ellipse">
@@ -4085,7 +4085,7 @@
           </p:nvSpPr>
           <p:spPr>
             <a:xfrm>
-              <a:off x="1995509" y="4113309"/>
+              <a:off x="1976114" y="4656550"/>
               <a:ext cx="49651" cy="49651"/>
             </a:xfrm>
             <a:prstGeom prst="ellipse">
@@ -4120,7 +4120,7 @@
           </p:nvSpPr>
           <p:spPr>
             <a:xfrm>
-              <a:off x="2070598" y="4113308"/>
+              <a:off x="2048254" y="4656549"/>
               <a:ext cx="49651" cy="49651"/>
             </a:xfrm>
             <a:prstGeom prst="ellipse">
@@ -4155,7 +4155,7 @@
           </p:nvSpPr>
           <p:spPr>
             <a:xfrm>
-              <a:off x="2145686" y="4113306"/>
+              <a:off x="2120394" y="4656547"/>
               <a:ext cx="49651" cy="49651"/>
             </a:xfrm>
             <a:prstGeom prst="ellipse">
@@ -4190,7 +4190,7 @@
           </p:nvSpPr>
           <p:spPr>
             <a:xfrm>
-              <a:off x="2220775" y="4113301"/>
+              <a:off x="2192534" y="4656541"/>
               <a:ext cx="49651" cy="49651"/>
             </a:xfrm>
             <a:prstGeom prst="ellipse">
@@ -4225,7 +4225,7 @@
           </p:nvSpPr>
           <p:spPr>
             <a:xfrm>
-              <a:off x="2295864" y="4113292"/>
+              <a:off x="2264674" y="4656530"/>
               <a:ext cx="49651" cy="49651"/>
             </a:xfrm>
             <a:prstGeom prst="ellipse">
@@ -4260,7 +4260,7 @@
           </p:nvSpPr>
           <p:spPr>
             <a:xfrm>
-              <a:off x="2370952" y="4113272"/>
+              <a:off x="2336814" y="4656507"/>
               <a:ext cx="49651" cy="49651"/>
             </a:xfrm>
             <a:prstGeom prst="ellipse">
@@ -4295,7 +4295,7 @@
           </p:nvSpPr>
           <p:spPr>
             <a:xfrm>
-              <a:off x="2446041" y="4113230"/>
+              <a:off x="2408955" y="4656458"/>
               <a:ext cx="49651" cy="49651"/>
             </a:xfrm>
             <a:prstGeom prst="ellipse">
@@ -4330,7 +4330,7 @@
           </p:nvSpPr>
           <p:spPr>
             <a:xfrm>
-              <a:off x="2521129" y="4113142"/>
+              <a:off x="2481095" y="4656354"/>
               <a:ext cx="49651" cy="49651"/>
             </a:xfrm>
             <a:prstGeom prst="ellipse">
@@ -4365,7 +4365,7 @@
           </p:nvSpPr>
           <p:spPr>
             <a:xfrm>
-              <a:off x="2596218" y="4112955"/>
+              <a:off x="2553235" y="4656136"/>
               <a:ext cx="49651" cy="49651"/>
             </a:xfrm>
             <a:prstGeom prst="ellipse">
@@ -4400,7 +4400,7 @@
           </p:nvSpPr>
           <p:spPr>
             <a:xfrm>
-              <a:off x="2671306" y="4112561"/>
+              <a:off x="2625375" y="4655673"/>
               <a:ext cx="49651" cy="49651"/>
             </a:xfrm>
             <a:prstGeom prst="ellipse">
@@ -4435,7 +4435,7 @@
           </p:nvSpPr>
           <p:spPr>
             <a:xfrm>
-              <a:off x="2746395" y="4111729"/>
+              <a:off x="2697515" y="4654698"/>
               <a:ext cx="49651" cy="49651"/>
             </a:xfrm>
             <a:prstGeom prst="ellipse">
@@ -4470,7 +4470,7 @@
           </p:nvSpPr>
           <p:spPr>
             <a:xfrm>
-              <a:off x="2821484" y="4109975"/>
+              <a:off x="2769655" y="4652643"/>
               <a:ext cx="49651" cy="49651"/>
             </a:xfrm>
             <a:prstGeom prst="ellipse">
@@ -4505,7 +4505,7 @@
           </p:nvSpPr>
           <p:spPr>
             <a:xfrm>
-              <a:off x="2896572" y="4106292"/>
+              <a:off x="2841795" y="4648325"/>
               <a:ext cx="49651" cy="49651"/>
             </a:xfrm>
             <a:prstGeom prst="ellipse">
@@ -4540,7 +4540,7 @@
           </p:nvSpPr>
           <p:spPr>
             <a:xfrm>
-              <a:off x="2971661" y="4098594"/>
+              <a:off x="2913935" y="4639301"/>
               <a:ext cx="49651" cy="49651"/>
             </a:xfrm>
             <a:prstGeom prst="ellipse">
@@ -4575,7 +4575,7 @@
           </p:nvSpPr>
           <p:spPr>
             <a:xfrm>
-              <a:off x="3046749" y="4082822"/>
+              <a:off x="2986075" y="4620813"/>
               <a:ext cx="49651" cy="49651"/>
             </a:xfrm>
             <a:prstGeom prst="ellipse">
@@ -4610,7 +4610,7 @@
           </p:nvSpPr>
           <p:spPr>
             <a:xfrm>
-              <a:off x="3121838" y="4050730"/>
+              <a:off x="3058215" y="4583193"/>
               <a:ext cx="49651" cy="49651"/>
             </a:xfrm>
             <a:prstGeom prst="ellipse">
@@ -4645,7 +4645,7 @@
           </p:nvSpPr>
           <p:spPr>
             <a:xfrm>
-              <a:off x="3196926" y="3992571"/>
+              <a:off x="3130355" y="4515018"/>
               <a:ext cx="49651" cy="49651"/>
             </a:xfrm>
             <a:prstGeom prst="ellipse">
@@ -4680,7 +4680,7 @@
           </p:nvSpPr>
           <p:spPr>
             <a:xfrm>
-              <a:off x="3272015" y="3884701"/>
+              <a:off x="3202495" y="4388568"/>
               <a:ext cx="49651" cy="49651"/>
             </a:xfrm>
             <a:prstGeom prst="ellipse">
@@ -4715,7 +4715,7 @@
           </p:nvSpPr>
           <p:spPr>
             <a:xfrm>
-              <a:off x="3347104" y="3720130"/>
+              <a:off x="3274635" y="4195654"/>
               <a:ext cx="49651" cy="49651"/>
             </a:xfrm>
             <a:prstGeom prst="ellipse">
@@ -4750,7 +4750,7 @@
           </p:nvSpPr>
           <p:spPr>
             <a:xfrm>
-              <a:off x="3422192" y="3509852"/>
+              <a:off x="3346776" y="3949160"/>
               <a:ext cx="49651" cy="49651"/>
             </a:xfrm>
             <a:prstGeom prst="ellipse">
@@ -4785,7 +4785,7 @@
           </p:nvSpPr>
           <p:spPr>
             <a:xfrm>
-              <a:off x="3497281" y="3436073"/>
+              <a:off x="3418916" y="3862673"/>
               <a:ext cx="49651" cy="49651"/>
             </a:xfrm>
             <a:prstGeom prst="ellipse">
@@ -4820,7 +4820,7 @@
           </p:nvSpPr>
           <p:spPr>
             <a:xfrm>
-              <a:off x="3572369" y="3375758"/>
+              <a:off x="3491056" y="3791970"/>
               <a:ext cx="49651" cy="49651"/>
             </a:xfrm>
             <a:prstGeom prst="ellipse">
@@ -4855,7 +4855,7 @@
           </p:nvSpPr>
           <p:spPr>
             <a:xfrm>
-              <a:off x="3647458" y="3333834"/>
+              <a:off x="3563196" y="3742826"/>
               <a:ext cx="49651" cy="49651"/>
             </a:xfrm>
             <a:prstGeom prst="ellipse">
@@ -4890,7 +4890,7 @@
           </p:nvSpPr>
           <p:spPr>
             <a:xfrm>
-              <a:off x="3722546" y="3121006"/>
+              <a:off x="3635336" y="3493343"/>
               <a:ext cx="49651" cy="49651"/>
             </a:xfrm>
             <a:prstGeom prst="ellipse">
@@ -4925,7 +4925,7 @@
           </p:nvSpPr>
           <p:spPr>
             <a:xfrm>
-              <a:off x="3797635" y="2761611"/>
+              <a:off x="3707476" y="3072048"/>
               <a:ext cx="49651" cy="49651"/>
             </a:xfrm>
             <a:prstGeom prst="ellipse">
@@ -4960,7 +4960,7 @@
           </p:nvSpPr>
           <p:spPr>
             <a:xfrm>
-              <a:off x="3872724" y="2361475"/>
+              <a:off x="3779616" y="2602996"/>
               <a:ext cx="49651" cy="49651"/>
             </a:xfrm>
             <a:prstGeom prst="ellipse">
@@ -4995,7 +4995,7 @@
           </p:nvSpPr>
           <p:spPr>
             <a:xfrm>
-              <a:off x="3947812" y="1894741"/>
+              <a:off x="3851756" y="2055876"/>
               <a:ext cx="49651" cy="49651"/>
             </a:xfrm>
             <a:prstGeom prst="ellipse">
@@ -5030,7 +5030,7 @@
           </p:nvSpPr>
           <p:spPr>
             <a:xfrm>
-              <a:off x="4022901" y="1534015"/>
+              <a:off x="3923896" y="1633022"/>
               <a:ext cx="49651" cy="49651"/>
             </a:xfrm>
             <a:prstGeom prst="ellipse">
@@ -5065,7 +5065,7 @@
           </p:nvSpPr>
           <p:spPr>
             <a:xfrm>
-              <a:off x="4097989" y="1212769"/>
+              <a:off x="3996036" y="1256448"/>
               <a:ext cx="49651" cy="49651"/>
             </a:xfrm>
             <a:prstGeom prst="ellipse">
@@ -5100,7 +5100,7 @@
           </p:nvSpPr>
           <p:spPr>
             <a:xfrm>
-              <a:off x="4173078" y="990392"/>
+              <a:off x="4068176" y="995770"/>
               <a:ext cx="49651" cy="49651"/>
             </a:xfrm>
             <a:prstGeom prst="ellipse">
@@ -5135,7 +5135,7 @@
           </p:nvSpPr>
           <p:spPr>
             <a:xfrm>
-              <a:off x="4248166" y="1429627"/>
+              <a:off x="4140316" y="1510655"/>
               <a:ext cx="49651" cy="49651"/>
             </a:xfrm>
             <a:prstGeom prst="ellipse">
@@ -5170,7 +5170,7 @@
           </p:nvSpPr>
           <p:spPr>
             <a:xfrm>
-              <a:off x="4323255" y="2052937"/>
+              <a:off x="4212456" y="2241319"/>
               <a:ext cx="49651" cy="49651"/>
             </a:xfrm>
             <a:prstGeom prst="ellipse">
@@ -5205,7 +5205,7 @@
           </p:nvSpPr>
           <p:spPr>
             <a:xfrm>
-              <a:off x="4398344" y="2417847"/>
+              <a:off x="4284597" y="2669078"/>
               <a:ext cx="49651" cy="49651"/>
             </a:xfrm>
             <a:prstGeom prst="ellipse">
@@ -5240,7 +5240,7 @@
           </p:nvSpPr>
           <p:spPr>
             <a:xfrm>
-              <a:off x="4473432" y="2726426"/>
+              <a:off x="4356737" y="3030803"/>
               <a:ext cx="49651" cy="49651"/>
             </a:xfrm>
             <a:prstGeom prst="ellipse">
@@ -5275,7 +5275,7 @@
           </p:nvSpPr>
           <p:spPr>
             <a:xfrm>
-              <a:off x="4548521" y="3075321"/>
+              <a:off x="4428877" y="3439789"/>
               <a:ext cx="49651" cy="49651"/>
             </a:xfrm>
             <a:prstGeom prst="ellipse">
@@ -5310,7 +5310,7 @@
           </p:nvSpPr>
           <p:spPr>
             <a:xfrm>
-              <a:off x="4623609" y="3235800"/>
+              <a:off x="4501017" y="3627907"/>
               <a:ext cx="49651" cy="49651"/>
             </a:xfrm>
             <a:prstGeom prst="ellipse">
@@ -5345,7 +5345,7 @@
           </p:nvSpPr>
           <p:spPr>
             <a:xfrm>
-              <a:off x="4698698" y="3197726"/>
+              <a:off x="4573157" y="3583275"/>
               <a:ext cx="49651" cy="49651"/>
             </a:xfrm>
             <a:prstGeom prst="ellipse">
@@ -5380,7 +5380,7 @@
           </p:nvSpPr>
           <p:spPr>
             <a:xfrm>
-              <a:off x="4773786" y="3032273"/>
+              <a:off x="4645297" y="3389327"/>
               <a:ext cx="49651" cy="49651"/>
             </a:xfrm>
             <a:prstGeom prst="ellipse">
@@ -5415,7 +5415,7 @@
           </p:nvSpPr>
           <p:spPr>
             <a:xfrm>
-              <a:off x="4848875" y="2727254"/>
+              <a:off x="4717437" y="3031774"/>
               <a:ext cx="49651" cy="49651"/>
             </a:xfrm>
             <a:prstGeom prst="ellipse">
@@ -5450,7 +5450,7 @@
           </p:nvSpPr>
           <p:spPr>
             <a:xfrm>
-              <a:off x="4923963" y="2526162"/>
+              <a:off x="4789577" y="2796048"/>
               <a:ext cx="49651" cy="49651"/>
             </a:xfrm>
             <a:prstGeom prst="ellipse">
@@ -5485,7 +5485,7 @@
           </p:nvSpPr>
           <p:spPr>
             <a:xfrm>
-              <a:off x="4999052" y="2361436"/>
+              <a:off x="4861717" y="2602951"/>
               <a:ext cx="49651" cy="49651"/>
             </a:xfrm>
             <a:prstGeom prst="ellipse">
@@ -5520,7 +5520,7 @@
           </p:nvSpPr>
           <p:spPr>
             <a:xfrm>
-              <a:off x="5074141" y="2526366"/>
+              <a:off x="4933857" y="2796287"/>
               <a:ext cx="49651" cy="49651"/>
             </a:xfrm>
             <a:prstGeom prst="ellipse">
@@ -5555,7 +5555,7 @@
           </p:nvSpPr>
           <p:spPr>
             <a:xfrm>
-              <a:off x="5149229" y="2829768"/>
+              <a:off x="5005997" y="3151944"/>
               <a:ext cx="49651" cy="49651"/>
             </a:xfrm>
             <a:prstGeom prst="ellipse">
@@ -5590,7 +5590,7 @@
           </p:nvSpPr>
           <p:spPr>
             <a:xfrm>
-              <a:off x="5224318" y="3316362"/>
+              <a:off x="5078137" y="3722345"/>
               <a:ext cx="49651" cy="49651"/>
             </a:xfrm>
             <a:prstGeom prst="ellipse">
@@ -5625,7 +5625,7 @@
           </p:nvSpPr>
           <p:spPr>
             <a:xfrm>
-              <a:off x="5299406" y="3625167"/>
+              <a:off x="5150277" y="4084335"/>
               <a:ext cx="49651" cy="49651"/>
             </a:xfrm>
             <a:prstGeom prst="ellipse">
@@ -5660,7 +5660,7 @@
           </p:nvSpPr>
           <p:spPr>
             <a:xfrm>
-              <a:off x="5374495" y="3817849"/>
+              <a:off x="5222418" y="4310203"/>
               <a:ext cx="49651" cy="49651"/>
             </a:xfrm>
             <a:prstGeom prst="ellipse">
@@ -5695,7 +5695,7 @@
           </p:nvSpPr>
           <p:spPr>
             <a:xfrm>
-              <a:off x="5449583" y="3911958"/>
+              <a:off x="5294558" y="4420520"/>
               <a:ext cx="49651" cy="49651"/>
             </a:xfrm>
             <a:prstGeom prst="ellipse">
@@ -5730,7 +5730,7 @@
           </p:nvSpPr>
           <p:spPr>
             <a:xfrm>
-              <a:off x="5524672" y="3971048"/>
+              <a:off x="5366698" y="4489788"/>
               <a:ext cx="49651" cy="49651"/>
             </a:xfrm>
             <a:prstGeom prst="ellipse">
@@ -5765,8 +5765,8 @@
           </p:nvSpPr>
           <p:spPr>
             <a:xfrm>
-              <a:off x="1149684" y="4094343"/>
-              <a:ext cx="319945" cy="84529"/>
+              <a:off x="1149725" y="4640641"/>
+              <a:ext cx="319674" cy="81473"/>
             </a:xfrm>
             <a:prstGeom prst="rect">
               <a:avLst/>
@@ -5778,9 +5778,6 @@
             <a:lstStyle/>
             <a:p>
               <a:pPr algn="l" marL="0" marR="0" indent="0">
-                <a:lnSpc>
-                  <a:spcPts val="880"/>
-                </a:lnSpc>
                 <a:spcBef>
                   <a:spcPts val="0"/>
                 </a:spcBef>
@@ -5789,7 +5786,7 @@
                 </a:spcAft>
               </a:pPr>
               <a:r>
-                <a:rPr sz="880">
+                <a:rPr sz="880" i="0" b="0">
                   <a:solidFill>
                     <a:srgbClr val="4D4D4D">
                       <a:alpha val="100000"/>
@@ -5811,8 +5808,8 @@
           </p:nvSpPr>
           <p:spPr>
             <a:xfrm>
-              <a:off x="1149684" y="3637929"/>
-              <a:ext cx="319945" cy="84529"/>
+              <a:off x="1149725" y="4105618"/>
+              <a:ext cx="319674" cy="81473"/>
             </a:xfrm>
             <a:prstGeom prst="rect">
               <a:avLst/>
@@ -5824,9 +5821,6 @@
             <a:lstStyle/>
             <a:p>
               <a:pPr algn="l" marL="0" marR="0" indent="0">
-                <a:lnSpc>
-                  <a:spcPts val="880"/>
-                </a:lnSpc>
                 <a:spcBef>
                   <a:spcPts val="0"/>
                 </a:spcBef>
@@ -5835,7 +5829,7 @@
                 </a:spcAft>
               </a:pPr>
               <a:r>
-                <a:rPr sz="880">
+                <a:rPr sz="880" i="0" b="0">
                   <a:solidFill>
                     <a:srgbClr val="4D4D4D">
                       <a:alpha val="100000"/>
@@ -5857,8 +5851,8 @@
           </p:nvSpPr>
           <p:spPr>
             <a:xfrm>
-              <a:off x="1149684" y="3181515"/>
-              <a:ext cx="319945" cy="84529"/>
+              <a:off x="1149725" y="3570595"/>
+              <a:ext cx="319674" cy="81473"/>
             </a:xfrm>
             <a:prstGeom prst="rect">
               <a:avLst/>
@@ -5870,9 +5864,6 @@
             <a:lstStyle/>
             <a:p>
               <a:pPr algn="l" marL="0" marR="0" indent="0">
-                <a:lnSpc>
-                  <a:spcPts val="880"/>
-                </a:lnSpc>
                 <a:spcBef>
                   <a:spcPts val="0"/>
                 </a:spcBef>
@@ -5881,7 +5872,7 @@
                 </a:spcAft>
               </a:pPr>
               <a:r>
-                <a:rPr sz="880">
+                <a:rPr sz="880" i="0" b="0">
                   <a:solidFill>
                     <a:srgbClr val="4D4D4D">
                       <a:alpha val="100000"/>
@@ -5903,8 +5894,8 @@
           </p:nvSpPr>
           <p:spPr>
             <a:xfrm>
-              <a:off x="1149684" y="2725101"/>
-              <a:ext cx="319945" cy="84529"/>
+              <a:off x="1149725" y="3035573"/>
+              <a:ext cx="319674" cy="81473"/>
             </a:xfrm>
             <a:prstGeom prst="rect">
               <a:avLst/>
@@ -5916,9 +5907,6 @@
             <a:lstStyle/>
             <a:p>
               <a:pPr algn="l" marL="0" marR="0" indent="0">
-                <a:lnSpc>
-                  <a:spcPts val="880"/>
-                </a:lnSpc>
                 <a:spcBef>
                   <a:spcPts val="0"/>
                 </a:spcBef>
@@ -5927,7 +5915,7 @@
                 </a:spcAft>
               </a:pPr>
               <a:r>
-                <a:rPr sz="880">
+                <a:rPr sz="880" i="0" b="0">
                   <a:solidFill>
                     <a:srgbClr val="4D4D4D">
                       <a:alpha val="100000"/>
@@ -5949,8 +5937,8 @@
           </p:nvSpPr>
           <p:spPr>
             <a:xfrm>
-              <a:off x="1149684" y="2268687"/>
-              <a:ext cx="319945" cy="84529"/>
+              <a:off x="1149725" y="2500550"/>
+              <a:ext cx="319674" cy="81473"/>
             </a:xfrm>
             <a:prstGeom prst="rect">
               <a:avLst/>
@@ -5962,9 +5950,6 @@
             <a:lstStyle/>
             <a:p>
               <a:pPr algn="l" marL="0" marR="0" indent="0">
-                <a:lnSpc>
-                  <a:spcPts val="880"/>
-                </a:lnSpc>
                 <a:spcBef>
                   <a:spcPts val="0"/>
                 </a:spcBef>
@@ -5973,7 +5958,7 @@
                 </a:spcAft>
               </a:pPr>
               <a:r>
-                <a:rPr sz="880">
+                <a:rPr sz="880" i="0" b="0">
                   <a:solidFill>
                     <a:srgbClr val="4D4D4D">
                       <a:alpha val="100000"/>
@@ -5995,8 +5980,8 @@
           </p:nvSpPr>
           <p:spPr>
             <a:xfrm>
-              <a:off x="1149684" y="1812273"/>
-              <a:ext cx="319945" cy="84529"/>
+              <a:off x="1149725" y="1965527"/>
+              <a:ext cx="319674" cy="81473"/>
             </a:xfrm>
             <a:prstGeom prst="rect">
               <a:avLst/>
@@ -6008,9 +5993,6 @@
             <a:lstStyle/>
             <a:p>
               <a:pPr algn="l" marL="0" marR="0" indent="0">
-                <a:lnSpc>
-                  <a:spcPts val="880"/>
-                </a:lnSpc>
                 <a:spcBef>
                   <a:spcPts val="0"/>
                 </a:spcBef>
@@ -6019,7 +6001,7 @@
                 </a:spcAft>
               </a:pPr>
               <a:r>
-                <a:rPr sz="880">
+                <a:rPr sz="880" i="0" b="0">
                   <a:solidFill>
                     <a:srgbClr val="4D4D4D">
                       <a:alpha val="100000"/>
@@ -6041,8 +6023,8 @@
           </p:nvSpPr>
           <p:spPr>
             <a:xfrm>
-              <a:off x="1149684" y="1355858"/>
-              <a:ext cx="319945" cy="84529"/>
+              <a:off x="1149725" y="1430505"/>
+              <a:ext cx="319674" cy="81473"/>
             </a:xfrm>
             <a:prstGeom prst="rect">
               <a:avLst/>
@@ -6054,9 +6036,6 @@
             <a:lstStyle/>
             <a:p>
               <a:pPr algn="l" marL="0" marR="0" indent="0">
-                <a:lnSpc>
-                  <a:spcPts val="880"/>
-                </a:lnSpc>
                 <a:spcBef>
                   <a:spcPts val="0"/>
                 </a:spcBef>
@@ -6065,7 +6044,7 @@
                 </a:spcAft>
               </a:pPr>
               <a:r>
-                <a:rPr sz="880">
+                <a:rPr sz="880" i="0" b="0">
                   <a:solidFill>
                     <a:srgbClr val="4D4D4D">
                       <a:alpha val="100000"/>
@@ -6087,7 +6066,7 @@
           </p:nvSpPr>
           <p:spPr>
             <a:xfrm>
-              <a:off x="1497465" y="4138136"/>
+              <a:off x="1497235" y="4681377"/>
               <a:ext cx="34794" cy="0"/>
             </a:xfrm>
             <a:custGeom>
@@ -6127,7 +6106,7 @@
           </p:nvSpPr>
           <p:spPr>
             <a:xfrm>
-              <a:off x="1497465" y="3681722"/>
+              <a:off x="1497235" y="4146354"/>
               <a:ext cx="34794" cy="0"/>
             </a:xfrm>
             <a:custGeom>
@@ -6167,7 +6146,7 @@
           </p:nvSpPr>
           <p:spPr>
             <a:xfrm>
-              <a:off x="1497465" y="3225307"/>
+              <a:off x="1497235" y="3611332"/>
               <a:ext cx="34794" cy="0"/>
             </a:xfrm>
             <a:custGeom>
@@ -6207,7 +6186,7 @@
           </p:nvSpPr>
           <p:spPr>
             <a:xfrm>
-              <a:off x="1497465" y="2768893"/>
+              <a:off x="1497235" y="3076309"/>
               <a:ext cx="34794" cy="0"/>
             </a:xfrm>
             <a:custGeom>
@@ -6247,7 +6226,7 @@
           </p:nvSpPr>
           <p:spPr>
             <a:xfrm>
-              <a:off x="1497465" y="2312479"/>
+              <a:off x="1497235" y="2541286"/>
               <a:ext cx="34794" cy="0"/>
             </a:xfrm>
             <a:custGeom>
@@ -6287,7 +6266,7 @@
           </p:nvSpPr>
           <p:spPr>
             <a:xfrm>
-              <a:off x="1497465" y="1856065"/>
+              <a:off x="1497235" y="2006264"/>
               <a:ext cx="34794" cy="0"/>
             </a:xfrm>
             <a:custGeom>
@@ -6327,7 +6306,7 @@
           </p:nvSpPr>
           <p:spPr>
             <a:xfrm>
-              <a:off x="1497465" y="1399651"/>
+              <a:off x="1497235" y="1471241"/>
               <a:ext cx="34794" cy="0"/>
             </a:xfrm>
             <a:custGeom>
@@ -6367,7 +6346,7 @@
           </p:nvSpPr>
           <p:spPr>
             <a:xfrm>
-              <a:off x="1532259" y="4169365"/>
+              <a:off x="1532030" y="4717985"/>
               <a:ext cx="0" cy="34794"/>
             </a:xfrm>
             <a:custGeom>
@@ -6407,7 +6386,7 @@
           </p:nvSpPr>
           <p:spPr>
             <a:xfrm>
-              <a:off x="1982791" y="4169365"/>
+              <a:off x="1964870" y="4717985"/>
               <a:ext cx="0" cy="34794"/>
             </a:xfrm>
             <a:custGeom>
@@ -6447,7 +6426,7 @@
           </p:nvSpPr>
           <p:spPr>
             <a:xfrm>
-              <a:off x="2433322" y="4169365"/>
+              <a:off x="2397710" y="4717985"/>
               <a:ext cx="0" cy="34794"/>
             </a:xfrm>
             <a:custGeom>
@@ -6487,7 +6466,7 @@
           </p:nvSpPr>
           <p:spPr>
             <a:xfrm>
-              <a:off x="2883854" y="4169365"/>
+              <a:off x="2830551" y="4717985"/>
               <a:ext cx="0" cy="34794"/>
             </a:xfrm>
             <a:custGeom>
@@ -6527,7 +6506,7 @@
           </p:nvSpPr>
           <p:spPr>
             <a:xfrm>
-              <a:off x="3334385" y="4169365"/>
+              <a:off x="3263391" y="4717985"/>
               <a:ext cx="0" cy="34794"/>
             </a:xfrm>
             <a:custGeom>
@@ -6567,7 +6546,7 @@
           </p:nvSpPr>
           <p:spPr>
             <a:xfrm>
-              <a:off x="3784917" y="4169365"/>
+              <a:off x="3696232" y="4717985"/>
               <a:ext cx="0" cy="34794"/>
             </a:xfrm>
             <a:custGeom>
@@ -6607,7 +6586,7 @@
           </p:nvSpPr>
           <p:spPr>
             <a:xfrm>
-              <a:off x="4235448" y="4169365"/>
+              <a:off x="4129072" y="4717985"/>
               <a:ext cx="0" cy="34794"/>
             </a:xfrm>
             <a:custGeom>
@@ -6647,7 +6626,7 @@
           </p:nvSpPr>
           <p:spPr>
             <a:xfrm>
-              <a:off x="4685979" y="4169365"/>
+              <a:off x="4561913" y="4717985"/>
               <a:ext cx="0" cy="34794"/>
             </a:xfrm>
             <a:custGeom>
@@ -6687,7 +6666,7 @@
           </p:nvSpPr>
           <p:spPr>
             <a:xfrm>
-              <a:off x="5136511" y="4169365"/>
+              <a:off x="4994753" y="4717985"/>
               <a:ext cx="0" cy="34794"/>
             </a:xfrm>
             <a:custGeom>
@@ -6727,7 +6706,7 @@
           </p:nvSpPr>
           <p:spPr>
             <a:xfrm>
-              <a:off x="5587042" y="4169365"/>
+              <a:off x="5427594" y="4717985"/>
               <a:ext cx="0" cy="34794"/>
             </a:xfrm>
             <a:custGeom>
@@ -6767,8 +6746,8 @@
           </p:nvSpPr>
           <p:spPr>
             <a:xfrm>
-              <a:off x="1496707" y="4228939"/>
-              <a:ext cx="71105" cy="84529"/>
+              <a:off x="1496505" y="4780615"/>
+              <a:ext cx="71048" cy="81473"/>
             </a:xfrm>
             <a:prstGeom prst="rect">
               <a:avLst/>
@@ -6780,9 +6759,6 @@
             <a:lstStyle/>
             <a:p>
               <a:pPr algn="l" marL="0" marR="0" indent="0">
-                <a:lnSpc>
-                  <a:spcPts val="880"/>
-                </a:lnSpc>
                 <a:spcBef>
                   <a:spcPts val="0"/>
                 </a:spcBef>
@@ -6791,7 +6767,7 @@
                 </a:spcAft>
               </a:pPr>
               <a:r>
-                <a:rPr sz="880">
+                <a:rPr sz="880" i="0" b="0">
                   <a:solidFill>
                     <a:srgbClr val="4D4D4D">
                       <a:alpha val="100000"/>
@@ -6813,8 +6789,8 @@
           </p:nvSpPr>
           <p:spPr>
             <a:xfrm>
-              <a:off x="1947238" y="4228939"/>
-              <a:ext cx="71105" cy="84529"/>
+              <a:off x="1929346" y="4780615"/>
+              <a:ext cx="71048" cy="81473"/>
             </a:xfrm>
             <a:prstGeom prst="rect">
               <a:avLst/>
@@ -6826,9 +6802,6 @@
             <a:lstStyle/>
             <a:p>
               <a:pPr algn="l" marL="0" marR="0" indent="0">
-                <a:lnSpc>
-                  <a:spcPts val="880"/>
-                </a:lnSpc>
                 <a:spcBef>
                   <a:spcPts val="0"/>
                 </a:spcBef>
@@ -6837,7 +6810,7 @@
                 </a:spcAft>
               </a:pPr>
               <a:r>
-                <a:rPr sz="880">
+                <a:rPr sz="880" i="0" b="0">
                   <a:solidFill>
                     <a:srgbClr val="4D4D4D">
                       <a:alpha val="100000"/>
@@ -6859,8 +6832,8 @@
           </p:nvSpPr>
           <p:spPr>
             <a:xfrm>
-              <a:off x="2362217" y="4230522"/>
-              <a:ext cx="142210" cy="82946"/>
+              <a:off x="2326662" y="4780615"/>
+              <a:ext cx="142097" cy="81473"/>
             </a:xfrm>
             <a:prstGeom prst="rect">
               <a:avLst/>
@@ -6872,9 +6845,6 @@
             <a:lstStyle/>
             <a:p>
               <a:pPr algn="l" marL="0" marR="0" indent="0">
-                <a:lnSpc>
-                  <a:spcPts val="880"/>
-                </a:lnSpc>
                 <a:spcBef>
                   <a:spcPts val="0"/>
                 </a:spcBef>
@@ -6883,7 +6853,7 @@
                 </a:spcAft>
               </a:pPr>
               <a:r>
-                <a:rPr sz="880">
+                <a:rPr sz="880" i="0" b="0">
                   <a:solidFill>
                     <a:srgbClr val="4D4D4D">
                       <a:alpha val="100000"/>
@@ -6905,8 +6875,8 @@
           </p:nvSpPr>
           <p:spPr>
             <a:xfrm>
-              <a:off x="2812749" y="4228939"/>
-              <a:ext cx="142210" cy="84529"/>
+              <a:off x="2759502" y="4780615"/>
+              <a:ext cx="142097" cy="81473"/>
             </a:xfrm>
             <a:prstGeom prst="rect">
               <a:avLst/>
@@ -6918,9 +6888,6 @@
             <a:lstStyle/>
             <a:p>
               <a:pPr algn="l" marL="0" marR="0" indent="0">
-                <a:lnSpc>
-                  <a:spcPts val="880"/>
-                </a:lnSpc>
                 <a:spcBef>
                   <a:spcPts val="0"/>
                 </a:spcBef>
@@ -6929,7 +6896,7 @@
                 </a:spcAft>
               </a:pPr>
               <a:r>
-                <a:rPr sz="880">
+                <a:rPr sz="880" i="0" b="0">
                   <a:solidFill>
                     <a:srgbClr val="4D4D4D">
                       <a:alpha val="100000"/>
@@ -6951,8 +6918,8 @@
           </p:nvSpPr>
           <p:spPr>
             <a:xfrm>
-              <a:off x="3263280" y="4230522"/>
-              <a:ext cx="142210" cy="82946"/>
+              <a:off x="3192342" y="4780615"/>
+              <a:ext cx="142097" cy="81473"/>
             </a:xfrm>
             <a:prstGeom prst="rect">
               <a:avLst/>
@@ -6964,9 +6931,6 @@
             <a:lstStyle/>
             <a:p>
               <a:pPr algn="l" marL="0" marR="0" indent="0">
-                <a:lnSpc>
-                  <a:spcPts val="880"/>
-                </a:lnSpc>
                 <a:spcBef>
                   <a:spcPts val="0"/>
                 </a:spcBef>
@@ -6975,7 +6939,7 @@
                 </a:spcAft>
               </a:pPr>
               <a:r>
-                <a:rPr sz="880">
+                <a:rPr sz="880" i="0" b="0">
                   <a:solidFill>
                     <a:srgbClr val="4D4D4D">
                       <a:alpha val="100000"/>
@@ -6997,8 +6961,8 @@
           </p:nvSpPr>
           <p:spPr>
             <a:xfrm>
-              <a:off x="3713811" y="4228939"/>
-              <a:ext cx="142210" cy="84529"/>
+              <a:off x="3625183" y="4780615"/>
+              <a:ext cx="142097" cy="81473"/>
             </a:xfrm>
             <a:prstGeom prst="rect">
               <a:avLst/>
@@ -7010,9 +6974,6 @@
             <a:lstStyle/>
             <a:p>
               <a:pPr algn="l" marL="0" marR="0" indent="0">
-                <a:lnSpc>
-                  <a:spcPts val="880"/>
-                </a:lnSpc>
                 <a:spcBef>
                   <a:spcPts val="0"/>
                 </a:spcBef>
@@ -7021,7 +6982,7 @@
                 </a:spcAft>
               </a:pPr>
               <a:r>
-                <a:rPr sz="880">
+                <a:rPr sz="880" i="0" b="0">
                   <a:solidFill>
                     <a:srgbClr val="4D4D4D">
                       <a:alpha val="100000"/>
@@ -7043,8 +7004,8 @@
           </p:nvSpPr>
           <p:spPr>
             <a:xfrm>
-              <a:off x="4164343" y="4228939"/>
-              <a:ext cx="142210" cy="84529"/>
+              <a:off x="4058023" y="4780615"/>
+              <a:ext cx="142097" cy="81473"/>
             </a:xfrm>
             <a:prstGeom prst="rect">
               <a:avLst/>
@@ -7056,9 +7017,6 @@
             <a:lstStyle/>
             <a:p>
               <a:pPr algn="l" marL="0" marR="0" indent="0">
-                <a:lnSpc>
-                  <a:spcPts val="880"/>
-                </a:lnSpc>
                 <a:spcBef>
                   <a:spcPts val="0"/>
                 </a:spcBef>
@@ -7067,7 +7025,7 @@
                 </a:spcAft>
               </a:pPr>
               <a:r>
-                <a:rPr sz="880">
+                <a:rPr sz="880" i="0" b="0">
                   <a:solidFill>
                     <a:srgbClr val="4D4D4D">
                       <a:alpha val="100000"/>
@@ -7089,8 +7047,8 @@
           </p:nvSpPr>
           <p:spPr>
             <a:xfrm>
-              <a:off x="4614874" y="4230522"/>
-              <a:ext cx="142210" cy="82946"/>
+              <a:off x="4490864" y="4780615"/>
+              <a:ext cx="142097" cy="81473"/>
             </a:xfrm>
             <a:prstGeom prst="rect">
               <a:avLst/>
@@ -7102,9 +7060,6 @@
             <a:lstStyle/>
             <a:p>
               <a:pPr algn="l" marL="0" marR="0" indent="0">
-                <a:lnSpc>
-                  <a:spcPts val="880"/>
-                </a:lnSpc>
                 <a:spcBef>
                   <a:spcPts val="0"/>
                 </a:spcBef>
@@ -7113,7 +7068,7 @@
                 </a:spcAft>
               </a:pPr>
               <a:r>
-                <a:rPr sz="880">
+                <a:rPr sz="880" i="0" b="0">
                   <a:solidFill>
                     <a:srgbClr val="4D4D4D">
                       <a:alpha val="100000"/>
@@ -7135,8 +7090,8 @@
           </p:nvSpPr>
           <p:spPr>
             <a:xfrm>
-              <a:off x="5065406" y="4228939"/>
-              <a:ext cx="142210" cy="84529"/>
+              <a:off x="4923704" y="4780615"/>
+              <a:ext cx="142097" cy="81473"/>
             </a:xfrm>
             <a:prstGeom prst="rect">
               <a:avLst/>
@@ -7148,9 +7103,6 @@
             <a:lstStyle/>
             <a:p>
               <a:pPr algn="l" marL="0" marR="0" indent="0">
-                <a:lnSpc>
-                  <a:spcPts val="880"/>
-                </a:lnSpc>
                 <a:spcBef>
                   <a:spcPts val="0"/>
                 </a:spcBef>
@@ -7159,7 +7111,7 @@
                 </a:spcAft>
               </a:pPr>
               <a:r>
-                <a:rPr sz="880">
+                <a:rPr sz="880" i="0" b="0">
                   <a:solidFill>
                     <a:srgbClr val="4D4D4D">
                       <a:alpha val="100000"/>
@@ -7181,8 +7133,8 @@
           </p:nvSpPr>
           <p:spPr>
             <a:xfrm>
-              <a:off x="5515937" y="4230412"/>
-              <a:ext cx="142210" cy="83056"/>
+              <a:off x="5356545" y="4780615"/>
+              <a:ext cx="142097" cy="81473"/>
             </a:xfrm>
             <a:prstGeom prst="rect">
               <a:avLst/>
@@ -7194,9 +7146,6 @@
             <a:lstStyle/>
             <a:p>
               <a:pPr algn="l" marL="0" marR="0" indent="0">
-                <a:lnSpc>
-                  <a:spcPts val="880"/>
-                </a:lnSpc>
                 <a:spcBef>
                   <a:spcPts val="0"/>
                 </a:spcBef>
@@ -7205,7 +7154,7 @@
                 </a:spcAft>
               </a:pPr>
               <a:r>
-                <a:rPr sz="880">
+                <a:rPr sz="880" i="0" b="0">
                   <a:solidFill>
                     <a:srgbClr val="4D4D4D">
                       <a:alpha val="100000"/>
@@ -7227,8 +7176,8 @@
           </p:nvSpPr>
           <p:spPr>
             <a:xfrm>
-              <a:off x="2880619" y="4338154"/>
-              <a:ext cx="1433152" cy="135197"/>
+              <a:off x="2804387" y="4920108"/>
+              <a:ext cx="1422989" cy="101864"/>
             </a:xfrm>
             <a:prstGeom prst="rect">
               <a:avLst/>
@@ -7240,9 +7189,6 @@
             <a:lstStyle/>
             <a:p>
               <a:pPr algn="l" marL="0" marR="0" indent="0">
-                <a:lnSpc>
-                  <a:spcPts val="1100"/>
-                </a:lnSpc>
                 <a:spcBef>
                   <a:spcPts val="0"/>
                 </a:spcBef>
@@ -7251,7 +7197,7 @@
                 </a:spcAft>
               </a:pPr>
               <a:r>
-                <a:rPr sz="1100">
+                <a:rPr sz="1100" i="0" b="0">
                   <a:solidFill>
                     <a:srgbClr val="000000">
                       <a:alpha val="100000"/>
@@ -7260,7 +7206,7 @@
                   <a:latin typeface="DejaVu Sans"/>
                   <a:cs typeface="DejaVu Sans"/>
                 </a:rPr>
-                <a:t>Days Post Challenge</a:t>
+                <a:t>Days post-challenge</a:t>
               </a:r>
             </a:p>
           </p:txBody>
@@ -7273,8 +7219,8 @@
           </p:nvSpPr>
           <p:spPr>
             <a:xfrm rot="-5400000">
-              <a:off x="783920" y="2522618"/>
-              <a:ext cx="495703" cy="108117"/>
+              <a:off x="788307" y="2800055"/>
+              <a:ext cx="493227" cy="101864"/>
             </a:xfrm>
             <a:prstGeom prst="rect">
               <a:avLst/>
@@ -7286,9 +7232,6 @@
             <a:lstStyle/>
             <a:p>
               <a:pPr algn="l" marL="0" marR="0" indent="0">
-                <a:lnSpc>
-                  <a:spcPts val="1100"/>
-                </a:lnSpc>
                 <a:spcBef>
                   <a:spcPts val="0"/>
                 </a:spcBef>
@@ -7297,7 +7240,7 @@
                 </a:spcAft>
               </a:pPr>
               <a:r>
-                <a:rPr sz="1100">
+                <a:rPr sz="1100" i="0" b="0">
                   <a:solidFill>
                     <a:srgbClr val="000000">
                       <a:alpha val="100000"/>
@@ -7319,8 +7262,8 @@
           </p:nvSpPr>
           <p:spPr>
             <a:xfrm>
-              <a:off x="5801309" y="2297115"/>
-              <a:ext cx="529901" cy="559123"/>
+              <a:off x="5638912" y="2571404"/>
+              <a:ext cx="509418" cy="559165"/>
             </a:xfrm>
             <a:prstGeom prst="rect">
               <a:avLst/>
@@ -7345,8 +7288,8 @@
           </p:nvSpPr>
           <p:spPr>
             <a:xfrm>
-              <a:off x="5870898" y="2381233"/>
-              <a:ext cx="390723" cy="101841"/>
+              <a:off x="5708501" y="2655532"/>
+              <a:ext cx="370240" cy="101864"/>
             </a:xfrm>
             <a:prstGeom prst="rect">
               <a:avLst/>
@@ -7358,9 +7301,6 @@
             <a:lstStyle/>
             <a:p>
               <a:pPr algn="l" marL="0" marR="0" indent="0">
-                <a:lnSpc>
-                  <a:spcPts val="1100"/>
-                </a:lnSpc>
                 <a:spcBef>
                   <a:spcPts val="0"/>
                 </a:spcBef>
@@ -7369,7 +7309,7 @@
                 </a:spcAft>
               </a:pPr>
               <a:r>
-                <a:rPr sz="1100">
+                <a:rPr sz="1100" i="0" b="0">
                   <a:solidFill>
                     <a:srgbClr val="000000">
                       <a:alpha val="100000"/>
@@ -7391,7 +7331,7 @@
           </p:nvSpPr>
           <p:spPr>
             <a:xfrm>
-              <a:off x="5870898" y="2567193"/>
+              <a:off x="5708501" y="2841524"/>
               <a:ext cx="219455" cy="219456"/>
             </a:xfrm>
             <a:prstGeom prst="rect">
@@ -7417,7 +7357,7 @@
           </p:nvSpPr>
           <p:spPr>
             <a:xfrm>
-              <a:off x="5892844" y="2676921"/>
+              <a:off x="5730446" y="2951252"/>
               <a:ext cx="175564" cy="0"/>
             </a:xfrm>
             <a:custGeom>
@@ -7451,49 +7391,14 @@
         </p:sp>
         <p:sp>
           <p:nvSpPr>
-            <p:cNvPr id="135" name="pt134"/>
-            <p:cNvSpPr/>
-            <p:nvPr/>
-          </p:nvSpPr>
-          <p:spPr>
-            <a:xfrm>
-              <a:off x="5955800" y="2652096"/>
-              <a:ext cx="49651" cy="49651"/>
-            </a:xfrm>
-            <a:prstGeom prst="ellipse">
-              <a:avLst/>
-            </a:prstGeom>
-            <a:solidFill>
-              <a:srgbClr val="F8766D">
-                <a:alpha val="100000"/>
-              </a:srgbClr>
-            </a:solidFill>
-            <a:ln w="9000" cap="rnd">
-              <a:solidFill>
-                <a:srgbClr val="F8766D">
-                  <a:alpha val="100000"/>
-                </a:srgbClr>
-              </a:solidFill>
-              <a:prstDash val="solid"/>
-              <a:round/>
-            </a:ln>
-          </p:spPr>
-          <p:txBody>
-            <a:bodyPr/>
-            <a:lstStyle/>
-            <a:p/>
-          </p:txBody>
-        </p:sp>
-        <p:sp>
-          <p:nvSpPr>
-            <p:cNvPr id="136" name="tx135"/>
-            <p:cNvSpPr/>
-            <p:nvPr/>
-          </p:nvSpPr>
-          <p:spPr>
-            <a:xfrm>
-              <a:off x="6159943" y="2636185"/>
-              <a:ext cx="76453" cy="81473"/>
+            <p:cNvPr id="135" name="tx134"/>
+            <p:cNvSpPr/>
+            <p:nvPr/>
+          </p:nvSpPr>
+          <p:spPr>
+            <a:xfrm>
+              <a:off x="5997546" y="2910516"/>
+              <a:ext cx="76443" cy="81473"/>
             </a:xfrm>
             <a:prstGeom prst="rect">
               <a:avLst/>
@@ -7505,9 +7410,6 @@
             <a:lstStyle/>
             <a:p>
               <a:pPr algn="l" marL="0" marR="0" indent="0">
-                <a:lnSpc>
-                  <a:spcPts val="880"/>
-                </a:lnSpc>
                 <a:spcBef>
                   <a:spcPts val="0"/>
                 </a:spcBef>
@@ -7516,7 +7418,7 @@
                 </a:spcAft>
               </a:pPr>
               <a:r>
-                <a:rPr sz="880">
+                <a:rPr sz="880" i="0" b="0">
                   <a:solidFill>
                     <a:srgbClr val="000000">
                       <a:alpha val="100000"/>

</xml_diff>